<commit_message>
add slide inspector and uml
</commit_message>
<xml_diff>
--- a/apps/mcp_ppt/templates/template_axenix.pptx
+++ b/apps/mcp_ppt/templates/template_axenix.pptx
@@ -232,7 +232,7 @@
           <a:p>
             <a:fld id="{ECFAD12D-9A74-460A-A1CD-2B068DAEEB73}" type="datetimeFigureOut">
               <a:rPr lang="ru-RU" smtClean="0"/>
-              <a:t>12.06.2026</a:t>
+              <a:t>13.06.2026</a:t>
             </a:fld>
             <a:endParaRPr lang="ru-RU" dirty="0"/>
           </a:p>
@@ -410,7 +410,7 @@
           <a:p>
             <a:fld id="{AB52C827-9368-4614-9CC8-CD634EA44F85}" type="datetimeFigureOut">
               <a:rPr lang="ru-RU" smtClean="0"/>
-              <a:t>12.06.2026</a:t>
+              <a:t>13.06.2026</a:t>
             </a:fld>
             <a:endParaRPr lang="ru-RU" dirty="0"/>
           </a:p>
@@ -1112,6 +1112,317 @@
 
 <file path=ppt/slideLayouts/slideLayout10.xml><?xml version="1.0" encoding="utf-8"?>
 <p:sldLayout xmlns:a="http://schemas.openxmlformats.org/drawingml/2006/main" xmlns:r="http://schemas.openxmlformats.org/officeDocument/2006/relationships" xmlns:p="http://schemas.openxmlformats.org/presentationml/2006/main" preserve="1" userDrawn="1">
+  <p:cSld name="1_Title and Content">
+    <p:spTree>
+      <p:nvGrpSpPr>
+        <p:cNvPr id="1" name=""/>
+        <p:cNvGrpSpPr/>
+        <p:nvPr/>
+      </p:nvGrpSpPr>
+      <p:grpSpPr>
+        <a:xfrm>
+          <a:off x="0" y="0"/>
+          <a:ext cx="0" cy="0"/>
+          <a:chOff x="0" y="0"/>
+          <a:chExt cx="0" cy="0"/>
+        </a:xfrm>
+      </p:grpSpPr>
+      <p:sp>
+        <p:nvSpPr>
+          <p:cNvPr id="4" name="Title Placeholder 1">
+            <a:extLst>
+              <a:ext uri="{FF2B5EF4-FFF2-40B4-BE49-F238E27FC236}">
+                <a16:creationId xmlns:a16="http://schemas.microsoft.com/office/drawing/2014/main" id="{C01E5B58-D84A-59E3-60BB-997737337292}"/>
+              </a:ext>
+            </a:extLst>
+          </p:cNvPr>
+          <p:cNvSpPr>
+            <a:spLocks noGrp="1"/>
+          </p:cNvSpPr>
+          <p:nvPr>
+            <p:ph type="title" hasCustomPrompt="1"/>
+          </p:nvPr>
+        </p:nvSpPr>
+        <p:spPr>
+          <a:xfrm>
+            <a:off x="1510748" y="381000"/>
+            <a:ext cx="10300252" cy="842890"/>
+          </a:xfrm>
+          <a:prstGeom prst="rect">
+            <a:avLst/>
+          </a:prstGeom>
+        </p:spPr>
+        <p:txBody>
+          <a:bodyPr vert="horz" lIns="0" tIns="45720" rIns="0" bIns="0" rtlCol="0" anchor="ctr" anchorCtr="0">
+            <a:normAutofit/>
+          </a:bodyPr>
+          <a:lstStyle>
+            <a:lvl1pPr>
+              <a:defRPr>
+                <a:latin typeface="Arial" panose="020B0604020202020204" pitchFamily="34" charset="0"/>
+              </a:defRPr>
+            </a:lvl1pPr>
+          </a:lstStyle>
+          <a:p>
+            <a:r>
+              <a:rPr lang="en-US" dirty="0"/>
+              <a:t>Headline place here (32pt)</a:t>
+            </a:r>
+            <a:br>
+              <a:rPr lang="en-US" dirty="0"/>
+            </a:br>
+            <a:endParaRPr lang="en-US" dirty="0"/>
+          </a:p>
+        </p:txBody>
+      </p:sp>
+      <p:sp>
+        <p:nvSpPr>
+          <p:cNvPr id="8" name="Text Placeholder 2">
+            <a:extLst>
+              <a:ext uri="{FF2B5EF4-FFF2-40B4-BE49-F238E27FC236}">
+                <a16:creationId xmlns:a16="http://schemas.microsoft.com/office/drawing/2014/main" id="{53C45B49-E277-AADE-2F63-1CBCC6F9BABF}"/>
+              </a:ext>
+            </a:extLst>
+          </p:cNvPr>
+          <p:cNvSpPr>
+            <a:spLocks noGrp="1"/>
+          </p:cNvSpPr>
+          <p:nvPr>
+            <p:ph type="body" idx="10" hasCustomPrompt="1"/>
+          </p:nvPr>
+        </p:nvSpPr>
+        <p:spPr>
+          <a:xfrm>
+            <a:off x="428399" y="1681163"/>
+            <a:ext cx="11407285" cy="823912"/>
+          </a:xfrm>
+          <a:prstGeom prst="rect">
+            <a:avLst/>
+          </a:prstGeom>
+        </p:spPr>
+        <p:txBody>
+          <a:bodyPr anchor="t"/>
+          <a:lstStyle>
+            <a:lvl1pPr marL="0" indent="0">
+              <a:lnSpc>
+                <a:spcPts val="1880"/>
+              </a:lnSpc>
+              <a:buNone/>
+              <a:defRPr sz="2400" b="1">
+                <a:solidFill>
+                  <a:srgbClr val="F37022"/>
+                </a:solidFill>
+                <a:latin typeface="Arial" panose="020B0604020202020204" pitchFamily="34" charset="0"/>
+              </a:defRPr>
+            </a:lvl1pPr>
+            <a:lvl2pPr marL="457200" indent="0">
+              <a:buNone/>
+              <a:defRPr sz="2000" b="1"/>
+            </a:lvl2pPr>
+            <a:lvl3pPr marL="914400" indent="0">
+              <a:buNone/>
+              <a:defRPr sz="1800" b="1"/>
+            </a:lvl3pPr>
+            <a:lvl4pPr marL="1371600" indent="0">
+              <a:buNone/>
+              <a:defRPr sz="1600" b="1"/>
+            </a:lvl4pPr>
+            <a:lvl5pPr marL="1828800" indent="0">
+              <a:buNone/>
+              <a:defRPr sz="1600" b="1"/>
+            </a:lvl5pPr>
+            <a:lvl6pPr marL="2286000" indent="0">
+              <a:buNone/>
+              <a:defRPr sz="1600" b="1"/>
+            </a:lvl6pPr>
+            <a:lvl7pPr marL="2743200" indent="0">
+              <a:buNone/>
+              <a:defRPr sz="1600" b="1"/>
+            </a:lvl7pPr>
+            <a:lvl8pPr marL="3200400" indent="0">
+              <a:buNone/>
+              <a:defRPr sz="1600" b="1"/>
+            </a:lvl8pPr>
+            <a:lvl9pPr marL="3657600" indent="0">
+              <a:buNone/>
+              <a:defRPr sz="1600" b="1"/>
+            </a:lvl9pPr>
+          </a:lstStyle>
+          <a:p>
+            <a:pPr lvl="0"/>
+            <a:r>
+              <a:rPr lang="en-US" dirty="0"/>
+              <a:t>Headline place here (24pt)</a:t>
+            </a:r>
+            <a:endParaRPr lang="en-GB" dirty="0"/>
+          </a:p>
+        </p:txBody>
+      </p:sp>
+      <p:sp>
+        <p:nvSpPr>
+          <p:cNvPr id="9" name="Content Placeholder 3">
+            <a:extLst>
+              <a:ext uri="{FF2B5EF4-FFF2-40B4-BE49-F238E27FC236}">
+                <a16:creationId xmlns:a16="http://schemas.microsoft.com/office/drawing/2014/main" id="{46A761EA-F6BB-976F-559B-39A621CF0289}"/>
+              </a:ext>
+            </a:extLst>
+          </p:cNvPr>
+          <p:cNvSpPr>
+            <a:spLocks noGrp="1"/>
+          </p:cNvSpPr>
+          <p:nvPr>
+            <p:ph sz="half" idx="2"/>
+          </p:nvPr>
+        </p:nvSpPr>
+        <p:spPr>
+          <a:xfrm>
+            <a:off x="428399" y="2608729"/>
+            <a:ext cx="11407285" cy="3580934"/>
+          </a:xfrm>
+          <a:prstGeom prst="rect">
+            <a:avLst/>
+          </a:prstGeom>
+        </p:spPr>
+        <p:txBody>
+          <a:bodyPr/>
+          <a:lstStyle>
+            <a:lvl1pPr marL="0" indent="0">
+              <a:buFontTx/>
+              <a:buNone/>
+              <a:defRPr sz="1600">
+                <a:latin typeface="Arial" panose="020B0604020202020204" pitchFamily="34" charset="0"/>
+              </a:defRPr>
+            </a:lvl1pPr>
+            <a:lvl2pPr marL="457200" indent="0">
+              <a:buFontTx/>
+              <a:buNone/>
+              <a:defRPr sz="1600">
+                <a:latin typeface="Arial" panose="020B0604020202020204" pitchFamily="34" charset="0"/>
+              </a:defRPr>
+            </a:lvl2pPr>
+            <a:lvl3pPr marL="914400" indent="0">
+              <a:buFontTx/>
+              <a:buNone/>
+              <a:defRPr sz="1600">
+                <a:latin typeface="Arial" panose="020B0604020202020204" pitchFamily="34" charset="0"/>
+              </a:defRPr>
+            </a:lvl3pPr>
+            <a:lvl4pPr marL="1371600" indent="0">
+              <a:buFontTx/>
+              <a:buNone/>
+              <a:defRPr sz="1600">
+                <a:latin typeface="Arial" panose="020B0604020202020204" pitchFamily="34" charset="0"/>
+              </a:defRPr>
+            </a:lvl4pPr>
+            <a:lvl5pPr marL="1828800" indent="0">
+              <a:buFontTx/>
+              <a:buNone/>
+              <a:defRPr sz="1600">
+                <a:latin typeface="Arial" panose="020B0604020202020204" pitchFamily="34" charset="0"/>
+              </a:defRPr>
+            </a:lvl5pPr>
+          </a:lstStyle>
+          <a:p>
+            <a:pPr lvl="0"/>
+            <a:r>
+              <a:rPr lang="en-GB" dirty="0"/>
+              <a:t>Click to edit Master text styles</a:t>
+            </a:r>
+          </a:p>
+          <a:p>
+            <a:pPr lvl="1"/>
+            <a:r>
+              <a:rPr lang="en-GB" dirty="0"/>
+              <a:t>Second level</a:t>
+            </a:r>
+          </a:p>
+          <a:p>
+            <a:pPr lvl="2"/>
+            <a:r>
+              <a:rPr lang="en-GB" dirty="0"/>
+              <a:t>Third level</a:t>
+            </a:r>
+          </a:p>
+          <a:p>
+            <a:pPr lvl="3"/>
+            <a:r>
+              <a:rPr lang="en-GB" dirty="0"/>
+              <a:t>Fourth level</a:t>
+            </a:r>
+          </a:p>
+          <a:p>
+            <a:pPr lvl="4"/>
+            <a:r>
+              <a:rPr lang="en-GB" dirty="0"/>
+              <a:t>Fifth level</a:t>
+            </a:r>
+            <a:endParaRPr lang="en-RU" dirty="0"/>
+          </a:p>
+        </p:txBody>
+      </p:sp>
+      <p:sp>
+        <p:nvSpPr>
+          <p:cNvPr id="3" name="Text Placeholder 6">
+            <a:extLst>
+              <a:ext uri="{FF2B5EF4-FFF2-40B4-BE49-F238E27FC236}">
+                <a16:creationId xmlns:a16="http://schemas.microsoft.com/office/drawing/2014/main" id="{A4FA1A80-78CE-5A24-E0FF-73A2D12DC622}"/>
+              </a:ext>
+            </a:extLst>
+          </p:cNvPr>
+          <p:cNvSpPr>
+            <a:spLocks noGrp="1"/>
+          </p:cNvSpPr>
+          <p:nvPr>
+            <p:ph type="body" sz="quarter" idx="12" hasCustomPrompt="1"/>
+          </p:nvPr>
+        </p:nvSpPr>
+        <p:spPr>
+          <a:xfrm>
+            <a:off x="1514341" y="850006"/>
+            <a:ext cx="10334222" cy="318884"/>
+          </a:xfrm>
+          <a:prstGeom prst="rect">
+            <a:avLst/>
+          </a:prstGeom>
+        </p:spPr>
+        <p:txBody>
+          <a:bodyPr lIns="0" tIns="0" rIns="0" bIns="0"/>
+          <a:lstStyle>
+            <a:lvl1pPr marL="0" indent="0">
+              <a:buFontTx/>
+              <a:buNone/>
+              <a:defRPr sz="2300" b="0" cap="none">
+                <a:solidFill>
+                  <a:schemeClr val="tx1"/>
+                </a:solidFill>
+                <a:latin typeface="Arial" panose="020B0604020202020204" pitchFamily="34" charset="0"/>
+              </a:defRPr>
+            </a:lvl1pPr>
+          </a:lstStyle>
+          <a:p>
+            <a:pPr lvl="0"/>
+            <a:r>
+              <a:rPr lang="en-US" dirty="0"/>
+              <a:t>Slide subtitle</a:t>
+            </a:r>
+          </a:p>
+        </p:txBody>
+      </p:sp>
+    </p:spTree>
+    <p:extLst>
+      <p:ext uri="{BB962C8B-B14F-4D97-AF65-F5344CB8AC3E}">
+        <p14:creationId xmlns:p14="http://schemas.microsoft.com/office/powerpoint/2010/main" val="1607887052"/>
+      </p:ext>
+    </p:extLst>
+  </p:cSld>
+  <p:clrMapOvr>
+    <a:masterClrMapping/>
+  </p:clrMapOvr>
+</p:sldLayout>
+</file>
+
+<file path=ppt/slideLayouts/slideLayout11.xml><?xml version="1.0" encoding="utf-8"?>
+<p:sldLayout xmlns:a="http://schemas.openxmlformats.org/drawingml/2006/main" xmlns:r="http://schemas.openxmlformats.org/officeDocument/2006/relationships" xmlns:p="http://schemas.openxmlformats.org/presentationml/2006/main" preserve="1" userDrawn="1">
   <p:cSld name="Two Content">
     <p:spTree>
       <p:nvGrpSpPr>
@@ -1572,7 +1883,7 @@
 </p:sldLayout>
 </file>
 
-<file path=ppt/slideLayouts/slideLayout11.xml><?xml version="1.0" encoding="utf-8"?>
+<file path=ppt/slideLayouts/slideLayout12.xml><?xml version="1.0" encoding="utf-8"?>
 <p:sldLayout xmlns:a="http://schemas.openxmlformats.org/drawingml/2006/main" xmlns:r="http://schemas.openxmlformats.org/officeDocument/2006/relationships" xmlns:p="http://schemas.openxmlformats.org/presentationml/2006/main" preserve="1" userDrawn="1">
   <p:cSld name="Comparison">
     <p:spTree>
@@ -2241,7 +2552,7 @@
 </p:sldLayout>
 </file>
 
-<file path=ppt/slideLayouts/slideLayout12.xml><?xml version="1.0" encoding="utf-8"?>
+<file path=ppt/slideLayouts/slideLayout13.xml><?xml version="1.0" encoding="utf-8"?>
 <p:sldLayout xmlns:a="http://schemas.openxmlformats.org/drawingml/2006/main" xmlns:r="http://schemas.openxmlformats.org/officeDocument/2006/relationships" xmlns:p="http://schemas.openxmlformats.org/presentationml/2006/main" preserve="1" userDrawn="1">
   <p:cSld name="2_Comparison">
     <p:spTree>
@@ -2851,9 +3162,9 @@
 </p:sldLayout>
 </file>
 
-<file path=ppt/slideLayouts/slideLayout13.xml><?xml version="1.0" encoding="utf-8"?>
+<file path=ppt/slideLayouts/slideLayout14.xml><?xml version="1.0" encoding="utf-8"?>
 <p:sldLayout xmlns:a="http://schemas.openxmlformats.org/drawingml/2006/main" xmlns:r="http://schemas.openxmlformats.org/officeDocument/2006/relationships" xmlns:p="http://schemas.openxmlformats.org/presentationml/2006/main" preserve="1" userDrawn="1">
-  <p:cSld name="sectiond dark">
+  <p:cSld name="section dark">
     <p:spTree>
       <p:nvGrpSpPr>
         <p:cNvPr id="1" name=""/>
@@ -2959,7 +3270,7 @@
 </p:sldLayout>
 </file>
 
-<file path=ppt/slideLayouts/slideLayout14.xml><?xml version="1.0" encoding="utf-8"?>
+<file path=ppt/slideLayouts/slideLayout15.xml><?xml version="1.0" encoding="utf-8"?>
 <p:sldLayout xmlns:a="http://schemas.openxmlformats.org/drawingml/2006/main" xmlns:r="http://schemas.openxmlformats.org/officeDocument/2006/relationships" xmlns:p="http://schemas.openxmlformats.org/presentationml/2006/main" showMasterSp="0" preserve="1" userDrawn="1">
   <p:cSld name="section light">
     <p:bg>
@@ -3161,7 +3472,7 @@
 </p:sldLayout>
 </file>
 
-<file path=ppt/slideLayouts/slideLayout15.xml><?xml version="1.0" encoding="utf-8"?>
+<file path=ppt/slideLayouts/slideLayout16.xml><?xml version="1.0" encoding="utf-8"?>
 <p:sldLayout xmlns:a="http://schemas.openxmlformats.org/drawingml/2006/main" xmlns:r="http://schemas.openxmlformats.org/officeDocument/2006/relationships" xmlns:p="http://schemas.openxmlformats.org/presentationml/2006/main" preserve="1" userDrawn="1">
   <p:cSld name="Closing - Light, Black Text">
     <p:spTree>
@@ -6115,7 +6426,7 @@
 
 <file path=ppt/slideLayouts/slideLayout9.xml><?xml version="1.0" encoding="utf-8"?>
 <p:sldLayout xmlns:a="http://schemas.openxmlformats.org/drawingml/2006/main" xmlns:r="http://schemas.openxmlformats.org/officeDocument/2006/relationships" xmlns:p="http://schemas.openxmlformats.org/presentationml/2006/main" preserve="1" userDrawn="1">
-  <p:cSld name="1_Title and Content">
+  <p:cSld name="Diagram with description">
     <p:spTree>
       <p:nvGrpSpPr>
         <p:cNvPr id="1" name=""/>
@@ -6132,10 +6443,93 @@
       </p:grpSpPr>
       <p:sp>
         <p:nvSpPr>
-          <p:cNvPr id="4" name="Title Placeholder 1">
+          <p:cNvPr id="8" name="Text Placeholder 2">
             <a:extLst>
               <a:ext uri="{FF2B5EF4-FFF2-40B4-BE49-F238E27FC236}">
-                <a16:creationId xmlns:a16="http://schemas.microsoft.com/office/drawing/2014/main" id="{C01E5B58-D84A-59E3-60BB-997737337292}"/>
+                <a16:creationId xmlns:a16="http://schemas.microsoft.com/office/drawing/2014/main" id="{53C45B49-E277-AADE-2F63-1CBCC6F9BABF}"/>
+              </a:ext>
+            </a:extLst>
+          </p:cNvPr>
+          <p:cNvSpPr>
+            <a:spLocks noGrp="1"/>
+          </p:cNvSpPr>
+          <p:nvPr>
+            <p:ph type="body" idx="10" hasCustomPrompt="1"/>
+          </p:nvPr>
+        </p:nvSpPr>
+        <p:spPr>
+          <a:xfrm>
+            <a:off x="428400" y="1681163"/>
+            <a:ext cx="11395514" cy="823912"/>
+          </a:xfrm>
+          <a:prstGeom prst="rect">
+            <a:avLst/>
+          </a:prstGeom>
+        </p:spPr>
+        <p:txBody>
+          <a:bodyPr anchor="t"/>
+          <a:lstStyle>
+            <a:lvl1pPr marL="0" indent="0">
+              <a:lnSpc>
+                <a:spcPts val="1880"/>
+              </a:lnSpc>
+              <a:buNone/>
+              <a:defRPr sz="2400" b="1">
+                <a:solidFill>
+                  <a:srgbClr val="F37022"/>
+                </a:solidFill>
+                <a:latin typeface="Arial" panose="020B0604020202020204" pitchFamily="34" charset="0"/>
+              </a:defRPr>
+            </a:lvl1pPr>
+            <a:lvl2pPr marL="457200" indent="0">
+              <a:buNone/>
+              <a:defRPr sz="2000" b="1"/>
+            </a:lvl2pPr>
+            <a:lvl3pPr marL="914400" indent="0">
+              <a:buNone/>
+              <a:defRPr sz="1800" b="1"/>
+            </a:lvl3pPr>
+            <a:lvl4pPr marL="1371600" indent="0">
+              <a:buNone/>
+              <a:defRPr sz="1600" b="1"/>
+            </a:lvl4pPr>
+            <a:lvl5pPr marL="1828800" indent="0">
+              <a:buNone/>
+              <a:defRPr sz="1600" b="1"/>
+            </a:lvl5pPr>
+            <a:lvl6pPr marL="2286000" indent="0">
+              <a:buNone/>
+              <a:defRPr sz="1600" b="1"/>
+            </a:lvl6pPr>
+            <a:lvl7pPr marL="2743200" indent="0">
+              <a:buNone/>
+              <a:defRPr sz="1600" b="1"/>
+            </a:lvl7pPr>
+            <a:lvl8pPr marL="3200400" indent="0">
+              <a:buNone/>
+              <a:defRPr sz="1600" b="1"/>
+            </a:lvl8pPr>
+            <a:lvl9pPr marL="3657600" indent="0">
+              <a:buNone/>
+              <a:defRPr sz="1600" b="1"/>
+            </a:lvl9pPr>
+          </a:lstStyle>
+          <a:p>
+            <a:pPr lvl="0"/>
+            <a:r>
+              <a:rPr lang="en-US" dirty="0"/>
+              <a:t>Headline place here (24pt)</a:t>
+            </a:r>
+            <a:endParaRPr lang="en-GB" dirty="0"/>
+          </a:p>
+        </p:txBody>
+      </p:sp>
+      <p:sp>
+        <p:nvSpPr>
+          <p:cNvPr id="10" name="Title Placeholder 1">
+            <a:extLst>
+              <a:ext uri="{FF2B5EF4-FFF2-40B4-BE49-F238E27FC236}">
+                <a16:creationId xmlns:a16="http://schemas.microsoft.com/office/drawing/2014/main" id="{B71D66D4-7B4F-A4A5-2D7D-403B84D4F2B0}"/>
               </a:ext>
             </a:extLst>
           </p:cNvPr>
@@ -6180,10 +6574,10 @@
       </p:sp>
       <p:sp>
         <p:nvSpPr>
-          <p:cNvPr id="8" name="Text Placeholder 2">
+          <p:cNvPr id="2" name="Picture Placeholder 18">
             <a:extLst>
               <a:ext uri="{FF2B5EF4-FFF2-40B4-BE49-F238E27FC236}">
-                <a16:creationId xmlns:a16="http://schemas.microsoft.com/office/drawing/2014/main" id="{53C45B49-E277-AADE-2F63-1CBCC6F9BABF}"/>
+                <a16:creationId xmlns:a16="http://schemas.microsoft.com/office/drawing/2014/main" id="{88A49B5E-0622-0DCA-5E61-9C6EC11281A8}"/>
               </a:ext>
             </a:extLst>
           </p:cNvPr>
@@ -6191,210 +6585,27 @@
             <a:spLocks noGrp="1"/>
           </p:cNvSpPr>
           <p:nvPr>
-            <p:ph type="body" idx="10" hasCustomPrompt="1"/>
+            <p:ph type="pic" sz="quarter" idx="13" hasCustomPrompt="1"/>
           </p:nvPr>
         </p:nvSpPr>
         <p:spPr>
           <a:xfrm>
-            <a:off x="428399" y="1681163"/>
-            <a:ext cx="11407285" cy="823912"/>
+            <a:off x="428400" y="2625754"/>
+            <a:ext cx="11395514" cy="3573567"/>
           </a:xfrm>
           <a:prstGeom prst="rect">
             <a:avLst/>
           </a:prstGeom>
+          <a:solidFill>
+            <a:schemeClr val="bg1"/>
+          </a:solidFill>
         </p:spPr>
         <p:txBody>
-          <a:bodyPr anchor="t"/>
+          <a:bodyPr tIns="274320" bIns="274320" anchor="ctr"/>
           <a:lstStyle>
-            <a:lvl1pPr marL="0" indent="0">
-              <a:lnSpc>
-                <a:spcPts val="1880"/>
-              </a:lnSpc>
-              <a:buNone/>
-              <a:defRPr sz="2400" b="1">
-                <a:solidFill>
-                  <a:srgbClr val="F37022"/>
-                </a:solidFill>
-                <a:latin typeface="Arial" panose="020B0604020202020204" pitchFamily="34" charset="0"/>
-              </a:defRPr>
-            </a:lvl1pPr>
-            <a:lvl2pPr marL="457200" indent="0">
-              <a:buNone/>
-              <a:defRPr sz="2000" b="1"/>
-            </a:lvl2pPr>
-            <a:lvl3pPr marL="914400" indent="0">
-              <a:buNone/>
-              <a:defRPr sz="1800" b="1"/>
-            </a:lvl3pPr>
-            <a:lvl4pPr marL="1371600" indent="0">
-              <a:buNone/>
-              <a:defRPr sz="1600" b="1"/>
-            </a:lvl4pPr>
-            <a:lvl5pPr marL="1828800" indent="0">
-              <a:buNone/>
-              <a:defRPr sz="1600" b="1"/>
-            </a:lvl5pPr>
-            <a:lvl6pPr marL="2286000" indent="0">
-              <a:buNone/>
-              <a:defRPr sz="1600" b="1"/>
-            </a:lvl6pPr>
-            <a:lvl7pPr marL="2743200" indent="0">
-              <a:buNone/>
-              <a:defRPr sz="1600" b="1"/>
-            </a:lvl7pPr>
-            <a:lvl8pPr marL="3200400" indent="0">
-              <a:buNone/>
-              <a:defRPr sz="1600" b="1"/>
-            </a:lvl8pPr>
-            <a:lvl9pPr marL="3657600" indent="0">
-              <a:buNone/>
-              <a:defRPr sz="1600" b="1"/>
-            </a:lvl9pPr>
-          </a:lstStyle>
-          <a:p>
-            <a:pPr lvl="0"/>
-            <a:r>
-              <a:rPr lang="en-US" dirty="0"/>
-              <a:t>Headline place here (24pt)</a:t>
-            </a:r>
-            <a:endParaRPr lang="en-GB" dirty="0"/>
-          </a:p>
-        </p:txBody>
-      </p:sp>
-      <p:sp>
-        <p:nvSpPr>
-          <p:cNvPr id="9" name="Content Placeholder 3">
-            <a:extLst>
-              <a:ext uri="{FF2B5EF4-FFF2-40B4-BE49-F238E27FC236}">
-                <a16:creationId xmlns:a16="http://schemas.microsoft.com/office/drawing/2014/main" id="{46A761EA-F6BB-976F-559B-39A621CF0289}"/>
-              </a:ext>
-            </a:extLst>
-          </p:cNvPr>
-          <p:cNvSpPr>
-            <a:spLocks noGrp="1"/>
-          </p:cNvSpPr>
-          <p:nvPr>
-            <p:ph sz="half" idx="2"/>
-          </p:nvPr>
-        </p:nvSpPr>
-        <p:spPr>
-          <a:xfrm>
-            <a:off x="428399" y="2608729"/>
-            <a:ext cx="11407285" cy="3580934"/>
-          </a:xfrm>
-          <a:prstGeom prst="rect">
-            <a:avLst/>
-          </a:prstGeom>
-        </p:spPr>
-        <p:txBody>
-          <a:bodyPr/>
-          <a:lstStyle>
-            <a:lvl1pPr marL="0" indent="0">
-              <a:buFontTx/>
-              <a:buNone/>
-              <a:defRPr sz="1600">
-                <a:latin typeface="Arial" panose="020B0604020202020204" pitchFamily="34" charset="0"/>
-              </a:defRPr>
-            </a:lvl1pPr>
-            <a:lvl2pPr marL="457200" indent="0">
-              <a:buFontTx/>
-              <a:buNone/>
-              <a:defRPr sz="1600">
-                <a:latin typeface="Arial" panose="020B0604020202020204" pitchFamily="34" charset="0"/>
-              </a:defRPr>
-            </a:lvl2pPr>
-            <a:lvl3pPr marL="914400" indent="0">
-              <a:buFontTx/>
-              <a:buNone/>
-              <a:defRPr sz="1600">
-                <a:latin typeface="Arial" panose="020B0604020202020204" pitchFamily="34" charset="0"/>
-              </a:defRPr>
-            </a:lvl3pPr>
-            <a:lvl4pPr marL="1371600" indent="0">
-              <a:buFontTx/>
-              <a:buNone/>
-              <a:defRPr sz="1600">
-                <a:latin typeface="Arial" panose="020B0604020202020204" pitchFamily="34" charset="0"/>
-              </a:defRPr>
-            </a:lvl4pPr>
-            <a:lvl5pPr marL="1828800" indent="0">
-              <a:buFontTx/>
-              <a:buNone/>
-              <a:defRPr sz="1600">
-                <a:latin typeface="Arial" panose="020B0604020202020204" pitchFamily="34" charset="0"/>
-              </a:defRPr>
-            </a:lvl5pPr>
-          </a:lstStyle>
-          <a:p>
-            <a:pPr lvl="0"/>
-            <a:r>
-              <a:rPr lang="en-GB" dirty="0"/>
-              <a:t>Click to edit Master text styles</a:t>
-            </a:r>
-          </a:p>
-          <a:p>
-            <a:pPr lvl="1"/>
-            <a:r>
-              <a:rPr lang="en-GB" dirty="0"/>
-              <a:t>Second level</a:t>
-            </a:r>
-          </a:p>
-          <a:p>
-            <a:pPr lvl="2"/>
-            <a:r>
-              <a:rPr lang="en-GB" dirty="0"/>
-              <a:t>Third level</a:t>
-            </a:r>
-          </a:p>
-          <a:p>
-            <a:pPr lvl="3"/>
-            <a:r>
-              <a:rPr lang="en-GB" dirty="0"/>
-              <a:t>Fourth level</a:t>
-            </a:r>
-          </a:p>
-          <a:p>
-            <a:pPr lvl="4"/>
-            <a:r>
-              <a:rPr lang="en-GB" dirty="0"/>
-              <a:t>Fifth level</a:t>
-            </a:r>
-            <a:endParaRPr lang="en-RU" dirty="0"/>
-          </a:p>
-        </p:txBody>
-      </p:sp>
-      <p:sp>
-        <p:nvSpPr>
-          <p:cNvPr id="3" name="Text Placeholder 6">
-            <a:extLst>
-              <a:ext uri="{FF2B5EF4-FFF2-40B4-BE49-F238E27FC236}">
-                <a16:creationId xmlns:a16="http://schemas.microsoft.com/office/drawing/2014/main" id="{A4FA1A80-78CE-5A24-E0FF-73A2D12DC622}"/>
-              </a:ext>
-            </a:extLst>
-          </p:cNvPr>
-          <p:cNvSpPr>
-            <a:spLocks noGrp="1"/>
-          </p:cNvSpPr>
-          <p:nvPr>
-            <p:ph type="body" sz="quarter" idx="12" hasCustomPrompt="1"/>
-          </p:nvPr>
-        </p:nvSpPr>
-        <p:spPr>
-          <a:xfrm>
-            <a:off x="1514341" y="850006"/>
-            <a:ext cx="10334222" cy="318884"/>
-          </a:xfrm>
-          <a:prstGeom prst="rect">
-            <a:avLst/>
-          </a:prstGeom>
-        </p:spPr>
-        <p:txBody>
-          <a:bodyPr lIns="0" tIns="0" rIns="0" bIns="0"/>
-          <a:lstStyle>
-            <a:lvl1pPr marL="0" indent="0">
-              <a:buFontTx/>
-              <a:buNone/>
-              <a:defRPr sz="2300" b="0" cap="none">
+            <a:lvl1pPr marL="0" indent="0" algn="ctr">
+              <a:buNone/>
+              <a:defRPr sz="1400" b="0">
                 <a:solidFill>
                   <a:schemeClr val="tx1"/>
                 </a:solidFill>
@@ -6403,18 +6614,18 @@
             </a:lvl1pPr>
           </a:lstStyle>
           <a:p>
-            <a:pPr lvl="0"/>
-            <a:r>
-              <a:rPr lang="en-US" dirty="0"/>
-              <a:t>Slide subtitle</a:t>
-            </a:r>
+            <a:r>
+              <a:rPr lang="en-GB" dirty="0"/>
+              <a:t>Add image</a:t>
+            </a:r>
+            <a:endParaRPr lang="en-US" dirty="0"/>
           </a:p>
         </p:txBody>
       </p:sp>
     </p:spTree>
     <p:extLst>
       <p:ext uri="{BB962C8B-B14F-4D97-AF65-F5344CB8AC3E}">
-        <p14:creationId xmlns:p14="http://schemas.microsoft.com/office/powerpoint/2010/main" val="1607887052"/>
+        <p14:creationId xmlns:p14="http://schemas.microsoft.com/office/powerpoint/2010/main" val="3544074130"/>
       </p:ext>
     </p:extLst>
   </p:cSld>
@@ -6625,7 +6836,7 @@
           <a:graphicData uri="http://schemas.openxmlformats.org/presentationml/2006/ole">
             <mc:AlternateContent xmlns:mc="http://schemas.openxmlformats.org/markup-compatibility/2006">
               <mc:Choice xmlns:v="urn:schemas-microsoft-com:vml" Requires="v">
-                <p:oleObj spid="_x0000_s1040" name="think-cell Folie" r:id="rId7" imgW="425" imgH="426" progId="TCLayout.ActiveDocument.1">
+                <p:oleObj spid="_x0000_s1046" name="think-cell Folie" r:id="rId7" imgW="425" imgH="426" progId="TCLayout.ActiveDocument.1">
                   <p:embed/>
                 </p:oleObj>
               </mc:Choice>
@@ -7120,7 +7331,7 @@
           <a:graphicData uri="http://schemas.openxmlformats.org/presentationml/2006/ole">
             <mc:AlternateContent xmlns:mc="http://schemas.openxmlformats.org/markup-compatibility/2006">
               <mc:Choice xmlns:v="urn:schemas-microsoft-com:vml" Requires="v">
-                <p:oleObj spid="_x0000_s2063" name="think-cell Folie" r:id="rId5" imgW="425" imgH="426" progId="TCLayout.ActiveDocument.1">
+                <p:oleObj spid="_x0000_s2069" name="think-cell Folie" r:id="rId5" imgW="425" imgH="426" progId="TCLayout.ActiveDocument.1">
                   <p:embed/>
                 </p:oleObj>
               </mc:Choice>
@@ -7869,7 +8080,7 @@
           <p:nvPr userDrawn="1"/>
         </p:nvPicPr>
         <p:blipFill rotWithShape="1">
-          <a:blip r:embed="rId11"/>
+          <a:blip r:embed="rId12"/>
           <a:srcRect/>
           <a:stretch/>
         </p:blipFill>
@@ -8074,10 +8285,11 @@
     <p:sldLayoutId id="2147483802" r:id="rId3"/>
     <p:sldLayoutId id="2147483803" r:id="rId4"/>
     <p:sldLayoutId id="2147483798" r:id="rId5"/>
-    <p:sldLayoutId id="2147483784" r:id="rId6"/>
-    <p:sldLayoutId id="2147483775" r:id="rId7"/>
-    <p:sldLayoutId id="2147483776" r:id="rId8"/>
-    <p:sldLayoutId id="2147483778" r:id="rId9"/>
+    <p:sldLayoutId id="2147483828" r:id="rId6"/>
+    <p:sldLayoutId id="2147483784" r:id="rId7"/>
+    <p:sldLayoutId id="2147483775" r:id="rId8"/>
+    <p:sldLayoutId id="2147483776" r:id="rId9"/>
+    <p:sldLayoutId id="2147483778" r:id="rId10"/>
   </p:sldLayoutIdLst>
   <p:txStyles>
     <p:titleStyle>
@@ -8404,7 +8616,7 @@
           <a:graphicData uri="http://schemas.openxmlformats.org/presentationml/2006/ole">
             <mc:AlternateContent xmlns:mc="http://schemas.openxmlformats.org/markup-compatibility/2006">
               <mc:Choice xmlns:v="urn:schemas-microsoft-com:vml" Requires="v">
-                <p:oleObj spid="_x0000_s3087" name="think-cell Folie" r:id="rId6" imgW="425" imgH="426" progId="TCLayout.ActiveDocument.1">
+                <p:oleObj spid="_x0000_s3093" name="think-cell Folie" r:id="rId6" imgW="425" imgH="426" progId="TCLayout.ActiveDocument.1">
                   <p:embed/>
                 </p:oleObj>
               </mc:Choice>
@@ -9138,7 +9350,7 @@
           <a:graphicData uri="http://schemas.openxmlformats.org/presentationml/2006/ole">
             <mc:AlternateContent xmlns:mc="http://schemas.openxmlformats.org/markup-compatibility/2006">
               <mc:Choice xmlns:v="urn:schemas-microsoft-com:vml" Requires="v">
-                <p:oleObj spid="_x0000_s4111" name="think-cell Folie" r:id="rId6" imgW="425" imgH="426" progId="TCLayout.ActiveDocument.1">
+                <p:oleObj spid="_x0000_s4117" name="think-cell Folie" r:id="rId6" imgW="425" imgH="426" progId="TCLayout.ActiveDocument.1">
                   <p:embed/>
                 </p:oleObj>
               </mc:Choice>
@@ -11830,18 +12042,18 @@
 </file>
 
 <file path=customXml/item2.xml><?xml version="1.0" encoding="utf-8"?>
+<p:properties xmlns:p="http://schemas.microsoft.com/office/2006/metadata/properties" xmlns:xsi="http://www.w3.org/2001/XMLSchema-instance" xmlns:pc="http://schemas.microsoft.com/office/infopath/2007/PartnerControls">
+  <documentManagement/>
+</p:properties>
+</file>
+
+<file path=customXml/item3.xml><?xml version="1.0" encoding="utf-8"?>
 <?mso-contentType ?>
 <FormTemplates xmlns="http://schemas.microsoft.com/sharepoint/v3/contenttype/forms">
   <Display>DocumentLibraryForm</Display>
   <Edit>DocumentLibraryForm</Edit>
   <New>DocumentLibraryForm</New>
 </FormTemplates>
-</file>
-
-<file path=customXml/item3.xml><?xml version="1.0" encoding="utf-8"?>
-<p:properties xmlns:p="http://schemas.microsoft.com/office/2006/metadata/properties" xmlns:xsi="http://www.w3.org/2001/XMLSchema-instance" xmlns:pc="http://schemas.microsoft.com/office/infopath/2007/PartnerControls">
-  <documentManagement/>
-</p:properties>
 </file>
 
 <file path=customXml/itemProps1.xml><?xml version="1.0" encoding="utf-8"?>
@@ -11861,18 +12073,18 @@
 </file>
 
 <file path=customXml/itemProps2.xml><?xml version="1.0" encoding="utf-8"?>
-<ds:datastoreItem xmlns:ds="http://schemas.openxmlformats.org/officeDocument/2006/customXml" ds:itemID="{BD286450-7DA9-49EF-8784-90E8814FA46D}">
-  <ds:schemaRefs>
-    <ds:schemaRef ds:uri="http://schemas.microsoft.com/sharepoint/v3/contenttype/forms"/>
-  </ds:schemaRefs>
-</ds:datastoreItem>
-</file>
-
-<file path=customXml/itemProps3.xml><?xml version="1.0" encoding="utf-8"?>
 <ds:datastoreItem xmlns:ds="http://schemas.openxmlformats.org/officeDocument/2006/customXml" ds:itemID="{26CBFB5A-E9DC-4C31-B655-546C90EABB4E}">
   <ds:schemaRefs>
     <ds:schemaRef ds:uri="http://schemas.microsoft.com/office/2006/metadata/properties"/>
     <ds:schemaRef ds:uri="http://schemas.microsoft.com/office/infopath/2007/PartnerControls"/>
   </ds:schemaRefs>
 </ds:datastoreItem>
+</file>
+
+<file path=customXml/itemProps3.xml><?xml version="1.0" encoding="utf-8"?>
+<ds:datastoreItem xmlns:ds="http://schemas.openxmlformats.org/officeDocument/2006/customXml" ds:itemID="{BD286450-7DA9-49EF-8784-90E8814FA46D}">
+  <ds:schemaRefs>
+    <ds:schemaRef ds:uri="http://schemas.microsoft.com/sharepoint/v3/contenttype/forms"/>
+  </ds:schemaRefs>
+</ds:datastoreItem>
 </file>
</xml_diff>